<commit_message>
Added script to monitory meshtastic battery life
</commit_message>
<xml_diff>
--- a/Presentations/presentation7.pptx
+++ b/Presentations/presentation7.pptx
@@ -14007,10 +14007,15 @@
             <p:ph idx="1"/>
           </p:nvPr>
         </p:nvSpPr>
-        <p:spPr/>
+        <p:spPr>
+          <a:xfrm>
+            <a:off x="838200" y="1572896"/>
+            <a:ext cx="10515600" cy="5032375"/>
+          </a:xfrm>
+        </p:spPr>
         <p:txBody>
           <a:bodyPr>
-            <a:normAutofit lnSpcReduction="10000"/>
+            <a:normAutofit fontScale="92500" lnSpcReduction="10000"/>
           </a:bodyPr>
           <a:lstStyle/>
           <a:p>
@@ -14038,11 +14043,20 @@
             <a:pPr lvl="1"/>
             <a:r>
               <a:rPr lang="en-CA" dirty="0"/>
-              <a:t>Although I assumed the node in the Collaborative Health Education Building (CHEB) had been recently re-flashed with default settings, I discovered this was not the case only after the test was completed. </a:t>
+              <a:t>Although I assumed the node in the Collaborative Health Education Building (CHEB) had been recently re-flashed with default settings, I discovered this was not the case only after the test was completed. Because the telemetry module was disabled, data collection was restricted to airUtilTx and packet counts. These metrics remained artificially low because routine background broadcasts were suppressed.</a:t>
             </a:r>
+            <a:endParaRPr lang="en-US" dirty="0"/>
+          </a:p>
+          <a:p>
             <a:r>
               <a:rPr lang="en-US" dirty="0"/>
-              <a:t>Because the background telemetry settings were turned off, I was only able to see the </a:t>
+              <a:t>This test could be re-done in the future with these changes for more data and accurate results.</a:t>
+            </a:r>
+          </a:p>
+          <a:p>
+            <a:r>
+              <a:rPr lang="en-US" dirty="0"/>
+              <a:t>Additionally, this test could be done with custom firmware I have written previously which exposes </a:t>
             </a:r>
             <a:r>
               <a:rPr lang="en-US" dirty="0" err="1"/>
@@ -14050,13 +14064,7 @@
             </a:r>
             <a:r>
               <a:rPr lang="en-US" dirty="0"/>
-              <a:t> and number of packets sent, which were low because the default background settings were turned off.</a:t>
-            </a:r>
-          </a:p>
-          <a:p>
-            <a:r>
-              <a:rPr lang="en-US" dirty="0"/>
-              <a:t>This test could be re-done in the future with these changes for more data and accurate results.</a:t>
+              <a:t> as milliseconds transferring packets since boot, instead of a percentage of time.</a:t>
             </a:r>
           </a:p>
           <a:p>

</xml_diff>